<commit_message>
Deck: reflect the $100 a month plan on every cost slide
Co-Authored-By: Claude Sonnet 5.5 <noreply@anthropic.com>
Claude-Session: https://claude.ai/code/session_01PXWkNosaoi9kedWjjba5Ek
</commit_message>
<xml_diff>
--- a/FinWebBuilder-changes-made.pptx
+++ b/FinWebBuilder-changes-made.pptx
@@ -759,7 +759,7 @@
                 <c:ptCount val="3"/>
                 <c:lvl>
                   <c:pt idx="0">
-                    <c:v>Claude Code, subscription (extra cash)</c:v>
+                    <c:v>Claude Code, $100/month plan (no charge per build)</c:v>
                   </c:pt>
                   <c:pt idx="1">
                     <c:v>Claude Code billed to an API key</c:v>
@@ -1407,7 +1407,7 @@
           <a:p>
             <a:r>
               <a:rPr lang="en-US" dirty="0"/>
-              <a:t>Assumptions for the direct API agent: same tokens as the Claude Code run, Haiku page reading replaced by Sonnet at $2 input and $10 output per million, searches unchanged at $10 per 1,000, Opus lead unchanged with caching. Actual API-agent token counts would differ. The plan fees are placeholders; replace with the real plan price.</a:t>
+              <a:t>Assumptions for the direct API agent: same tokens as the Claude Code run, Haiku page reading replaced by Sonnet at $2 input and $10 output per million, searches unchanged at $10 per 1,000, Opus lead unchanged with caching. Actual API-agent token counts would differ. The plan fee is $100 a month as Kumar stated; treated as US$ at the deck exchange rate (S$127.7), so break-even is 127.7 / 12.80 = about 10 large builds or 127.7 / 2 = 64 small ones.</a:t>
             </a:r>
             <a:endParaRPr lang="en-US" dirty="0"/>
           </a:p>
@@ -3563,7 +3563,7 @@
                 <a:ea typeface="Calibri" pitchFamily="34" charset="-122"/>
                 <a:cs typeface="Calibri" pitchFamily="34" charset="-120"/>
               </a:rPr>
-              <a:t>Subscription: S$0.00 extra. The run uses plan allowance worth S$12.51 at API rates, as Claude Code reports.</a:t>
+              <a:t>Subscription: the $100 a month plan covers it, with no charge per build. The run uses plan allowance worth S$12.51 at API rates, as Claude Code reports; limits reset weekly.</a:t>
             </a:r>
             <a:endParaRPr lang="en-US" sz="1400" dirty="0"/>
           </a:p>
@@ -3626,7 +3626,7 @@
                 <a:ea typeface="Calibri" pitchFamily="34" charset="-122"/>
                 <a:cs typeface="Calibri" pitchFamily="34" charset="-120"/>
               </a:rPr>
-              <a:t>A plan fee only pays off if you build enough: plan fee ÷ S$12.80 large builds a month. S$130 ≈ 10; S$260 ≈ 20 (example fees, not yours).</a:t>
+              <a:t>Taking $100 as US$ (about S$128), the plan matches the API bill at about 10 large builds a month (S$12.80 each) or 64 small ones (S$2 each).</a:t>
             </a:r>
             <a:endParaRPr lang="en-US" sz="1400" dirty="0"/>
           </a:p>
@@ -3665,7 +3665,7 @@
                 <a:ea typeface="Calibri" pitchFamily="34" charset="-122"/>
                 <a:cs typeface="Calibri" pitchFamily="34" charset="-120"/>
               </a:rPr>
-              <a:t>Measured: S$12.51 reported, S$12.80 estimated. Estimated: the direct API figure and the plan examples.</a:t>
+              <a:t>Measured: S$12.51 reported, S$12.80 estimated. Estimated: the direct API figure and the break-even (taking $100 as US$).</a:t>
             </a:r>
             <a:endParaRPr lang="en-US" sz="1100" dirty="0"/>
           </a:p>
@@ -6048,7 +6048,7 @@
                 <a:ea typeface="Calibri" pitchFamily="34" charset="-122"/>
                 <a:cs typeface="Calibri" pitchFamily="34" charset="-120"/>
               </a:rPr>
-              <a:t>The HDB build costs S$0.00 extra on the subscription and S$12.80 on an API key; a direct API agent would likely cost nearer S$23.55.</a:t>
+              <a:t>The $100 a month plan covers the HDB build, against S$12.80 on an API key; a direct API agent would likely cost nearer S$23.55.</a:t>
             </a:r>
             <a:endParaRPr lang="en-US" sz="1900" dirty="0"/>
           </a:p>
@@ -6286,7 +6286,7 @@
                 <a:ea typeface="Calibri" pitchFamily="34" charset="-122"/>
                 <a:cs typeface="Calibri" pitchFamily="34" charset="-120"/>
               </a:rPr>
-              <a:t>Estimated: every S$ figure other than reported ones, the direct API agent, the cache savings and the plan examples.</a:t>
+              <a:t>Estimated: every S$ figure other than reported ones, the direct API agent, the cache savings and the plan break-even.</a:t>
             </a:r>
             <a:endParaRPr lang="en-US" sz="1600" dirty="0"/>
           </a:p>
@@ -6992,7 +6992,7 @@
                 <a:ea typeface="Calibri" pitchFamily="34" charset="-122"/>
                 <a:cs typeface="Calibri" pitchFamily="34" charset="-120"/>
               </a:rPr>
-              <a:t>the HDB build costs S$0.00 extra on the subscription and S$12.80 if billed to an API key (Claude Code reported S$12.51).</a:t>
+              <a:t>the $100 a month plan covers the HDB build with no charge per build; billed to an API key it is S$12.80 (Claude Code reported S$12.51).</a:t>
             </a:r>
             <a:endParaRPr lang="en-US" sz="1800" dirty="0"/>
           </a:p>

</xml_diff>

<commit_message>
Deck: plan-share estimate on the cost chart, S$130 plan fee
Co-Authored-By: Claude Sonnet 5.5 <noreply@anthropic.com>
Claude-Session: https://claude.ai/code/session_01PXWkNosaoi9kedWjjba5Ek
</commit_message>
<xml_diff>
--- a/FinWebBuilder-changes-made.pptx
+++ b/FinWebBuilder-changes-made.pptx
@@ -470,18 +470,21 @@
           </c:dLbls>
           <c:cat>
             <c:multiLvlStrRef>
-              <c:f>Sheet1!$A$2:$A$4</c:f>
+              <c:f>Sheet1!$A$2:$A$5</c:f>
               <c:multiLvlStrCache>
-                <c:ptCount val="3"/>
+                <c:ptCount val="4"/>
                 <c:lvl>
                   <c:pt idx="0">
-                    <c:v>Claude Code, $100/month plan (no charge per build)</c:v>
+                    <c:v>Claude Code billed to an API key</c:v>
                   </c:pt>
                   <c:pt idx="1">
-                    <c:v>Claude Code billed to an API key</c:v>
+                    <c:v>On the plan: high case (55M weekly tokens)</c:v>
                   </c:pt>
                   <c:pt idx="2">
-                    <c:v>Direct API agent, Sonnet reads pages (estimate)</c:v>
+                    <c:v>On the plan: mid case (110M)</c:v>
+                  </c:pt>
+                  <c:pt idx="3">
+                    <c:v>On the plan: low case (220M)</c:v>
                   </c:pt>
                 </c:lvl>
               </c:multiLvlStrCache>
@@ -489,18 +492,21 @@
           </c:cat>
           <c:val>
             <c:numRef>
-              <c:f>Sheet1!$B$2:$B$4</c:f>
+              <c:f>Sheet1!$B$2:$B$5</c:f>
               <c:numCache>
                 <c:formatCode>General</c:formatCode>
-                <c:ptCount val="3"/>
+                <c:ptCount val="4"/>
                 <c:pt idx="0">
-                  <c:v>0</c:v>
+                  <c:v>12.8</c:v>
                 </c:pt>
                 <c:pt idx="1">
-                  <c:v>12.8</c:v>
+                  <c:v>4.6</c:v>
                 </c:pt>
                 <c:pt idx="2">
-                  <c:v>23.55</c:v>
+                  <c:v>2.3</c:v>
+                </c:pt>
+                <c:pt idx="3">
+                  <c:v>1.15</c:v>
                 </c:pt>
               </c:numCache>
             </c:numRef>
@@ -2003,7 +2009,7 @@
           <a:p>
             <a:r>
               <a:rPr lang="en-US" dirty="0"/>
-              <a:t>Assumptions for the direct API agent: same tokens as the Claude Code run, Haiku page reading replaced by Sonnet at $2 input and $10 output per million, searches unchanged at $10 per 1,000, Opus lead unchanged with caching. Actual API-agent token counts would differ. The plan fee is $100 a month as Kumar stated; treated as US$ at the deck exchange rate (S$127.7), so break-even is 127.7 / 12.80 = about 10 large builds or 127.7 / 2 = 64 small ones.</a:t>
+              <a:t>Plan share method: S$130 per month divided by 4 gives S$32.50 per week. The build used 7,776,549 tokens (Haiku 3.26M input and 0.23M output; Opus 0.54M cache writes, 3.55M cache reads, 0.19M output). Anthropic publishes no weekly token cap for the plan, so three caps are assumed: 55M, 110M and 220M tokens. Cost = tokens used / cap x S$32.50, which gives S$4.60, S$2.30 and S$1.15. All tokens are counted equally; a plan may weigh Opus and cached tokens differently.</a:t>
             </a:r>
             <a:endParaRPr lang="en-US" dirty="0"/>
           </a:p>
@@ -3249,7 +3255,7 @@
                           <a:ea typeface="Calibri" pitchFamily="34" charset="-122"/>
                           <a:cs typeface="Calibri" pitchFamily="34" charset="-120"/>
                         </a:rPr>
-                        <a:t>$100 a month for the plan, however many builds you run</a:t>
+                        <a:t>S$130 a month for the plan, however many builds you run</a:t>
                       </a:r>
                       <a:endParaRPr lang="en-US" sz="1400" dirty="0">
                         <a:latin typeface="Calibri" charset="0"/>
@@ -5150,7 +5156,7 @@
                 <a:ea typeface="Calibri" pitchFamily="34" charset="-122"/>
                 <a:cs typeface="Calibri" pitchFamily="34" charset="-120"/>
               </a:rPr>
-              <a:t>Estimated: every S$ figure other than reported ones, the direct API agent, the cache savings and the plan break-even.</a:t>
+              <a:t>Estimated: every S$ figure other than reported ones, the plan-share bars (assumed weekly token cap), the cache savings and the plan break-even.</a:t>
             </a:r>
             <a:endParaRPr lang="en-US" sz="1600" dirty="0"/>
           </a:p>
@@ -5856,7 +5862,7 @@
                 <a:ea typeface="Calibri" pitchFamily="34" charset="-122"/>
                 <a:cs typeface="Calibri" pitchFamily="34" charset="-120"/>
               </a:rPr>
-              <a:t>the $100 a month plan covers the HDB build with no charge per build; billed to an API key it is S$12.80 (Claude Code reported S$12.51).</a:t>
+              <a:t>on the S$130 a month plan the HDB build is an estimated S$2.30 (range S$1.15 to S$4.60) of plan allowance; billed to an API key it is S$12.80 (Claude Code reported S$12.51).</a:t>
             </a:r>
             <a:endParaRPr lang="en-US" sz="1800" dirty="0"/>
           </a:p>
@@ -16033,7 +16039,7 @@
                 <a:ea typeface="Calibri" pitchFamily="34" charset="-122"/>
                 <a:cs typeface="Calibri" pitchFamily="34" charset="-120"/>
               </a:rPr>
-              <a:t>The third bar swaps Haiku page reading for Sonnet at the same token counts ($2 / $10 per million): S$23.55. It is an estimate, not a run, and sits close to the agent’s default S$25 spending cap.</a:t>
+              <a:t>Plan bars: S$130 ÷ 4 = S$32.50 a week, times the build’s 7.78M tokens as a share of an assumed weekly token cap. The cap is unpublished, so these are estimates.</a:t>
             </a:r>
             <a:endParaRPr lang="en-US" sz="1200" dirty="0"/>
           </a:p>
@@ -16142,7 +16148,7 @@
                 <a:ea typeface="Calibri" pitchFamily="34" charset="-122"/>
                 <a:cs typeface="Calibri" pitchFamily="34" charset="-120"/>
               </a:rPr>
-              <a:t>Subscription: the $100 a month plan covers it, with no charge per build. The run uses plan allowance worth S$12.51 at API rates, as Claude Code reports; limits reset weekly.</a:t>
+              <a:t>Plan: S$130 a month is S$32.50 a week. The build’s 7.78M tokens are 3.5% to 14.1% of an assumed weekly allowance, so about S$1.15 to S$4.60 (mid S$2.30). Limits reset weekly.</a:t>
             </a:r>
             <a:endParaRPr lang="en-US" sz="1400" dirty="0"/>
           </a:p>
@@ -16184,28 +16190,7 @@
                 <a:ea typeface="Calibri" pitchFamily="34" charset="-122"/>
                 <a:cs typeface="Calibri" pitchFamily="34" charset="-120"/>
               </a:rPr>
-              <a:t>Direct API agent: it builds comparisons only today, so it cannot make this estimate calculator yet.</a:t>
-            </a:r>
-            <a:endParaRPr lang="en-US" sz="1400" dirty="0"/>
-          </a:p>
-          <a:p>
-            <a:pPr marL="342900" indent="-342900">
-              <a:spcAft>
-                <a:spcPts val="900"/>
-              </a:spcAft>
-              <a:buSzPct val="100000"/>
-              <a:buChar char="•"/>
-            </a:pPr>
-            <a:r>
-              <a:rPr lang="en-US" sz="1400" dirty="0">
-                <a:solidFill>
-                  <a:srgbClr val="181C1E"/>
-                </a:solidFill>
-                <a:latin typeface="Calibri" pitchFamily="34" charset="0"/>
-                <a:ea typeface="Calibri" pitchFamily="34" charset="-122"/>
-                <a:cs typeface="Calibri" pitchFamily="34" charset="-120"/>
-              </a:rPr>
-              <a:t>Taking $100 as US$ (about S$128), the plan matches the API bill at about 10 large builds a month (S$12.80 each) or 64 small ones (S$2 each).</a:t>
+              <a:t>At S$130 a month, the plan matches the API bill at about 10 large builds a month (S$12.80 each) or 65 small ones (S$2 each).</a:t>
             </a:r>
             <a:endParaRPr lang="en-US" sz="1400" dirty="0"/>
           </a:p>
@@ -16244,7 +16229,7 @@
                 <a:ea typeface="Calibri" pitchFamily="34" charset="-122"/>
                 <a:cs typeface="Calibri" pitchFamily="34" charset="-120"/>
               </a:rPr>
-              <a:t>Measured: S$12.51 reported, S$12.80 estimated. Estimated: the direct API figure and the break-even (taking $100 as US$).</a:t>
+              <a:t>Measured: S$12.51 reported, S$12.80 estimated. Estimated: the plan bars (assumed weekly token cap) and the break-even.</a:t>
             </a:r>
             <a:endParaRPr lang="en-US" sz="1100" dirty="0"/>
           </a:p>

</xml_diff>